<commit_message>
Slides: keep the SLO qualifier (sd-13-019), shorten the limit bullets (sd-13-019, sd-13-020)
Co-Authored-By: Claude Sonnet 5.5 <noreply@anthropic.com>
Claude-Session: https://claude.ai/code/session_01EhxTYrCJpuk4mcqCLwPdds
</commit_message>
<xml_diff>
--- a/system-design-101/vi/lessons/sd-13-019/slides/sd-13-019.pptx
+++ b/system-design-101/vi/lessons/sd-13-019/slides/sd-13-019.pptx
@@ -9970,7 +9970,7 @@
               <a:buNone/>
             </a:pPr>
             <a:r>
-              <a:rPr lang="en-US" sz="2850" dirty="0" spc="-144" kern="0">
+              <a:rPr lang="en-US" sz="2850" dirty="0" spc="-5" kern="0">
                 <a:solidFill>
                   <a:srgbClr val="14161C"/>
                 </a:solidFill>
@@ -9978,10 +9978,10 @@
                 <a:ea typeface="Be Vietnam Pro SemiBold" pitchFamily="34" charset="-122"/>
                 <a:cs typeface="Be Vietnam Pro SemiBold" pitchFamily="34" charset="-120"/>
               </a:rPr>
-              <a:t>Tổ</a:t>
-            </a:r>
-            <a:r>
-              <a:rPr lang="en-US" sz="2850" dirty="0" spc="13" kern="0">
+              <a:t>Nhỏ</a:t>
+            </a:r>
+            <a:r>
+              <a:rPr lang="en-US" sz="2850" dirty="0" spc="1" kern="0">
                 <a:solidFill>
                   <a:srgbClr val="14161C"/>
                 </a:solidFill>
@@ -9989,10 +9989,10 @@
                 <a:ea typeface="Be Vietnam Pro SemiBold" pitchFamily="34" charset="-122"/>
                 <a:cs typeface="Be Vietnam Pro SemiBold" pitchFamily="34" charset="-120"/>
               </a:rPr>
-              <a:t> chức</a:t>
-            </a:r>
-            <a:r>
-              <a:rPr lang="en-US" sz="2850" dirty="0" spc="-4" kern="0">
+              <a:t> thì</a:t>
+            </a:r>
+            <a:r>
+              <a:rPr lang="en-US" sz="2850" dirty="0" spc="11" kern="0">
                 <a:solidFill>
                   <a:srgbClr val="14161C"/>
                 </a:solidFill>
@@ -10000,10 +10000,10 @@
                 <a:ea typeface="Be Vietnam Pro SemiBold" pitchFamily="34" charset="-122"/>
                 <a:cs typeface="Be Vietnam Pro SemiBold" pitchFamily="34" charset="-120"/>
               </a:rPr>
-              <a:t> nhỏ</a:t>
-            </a:r>
-            <a:r>
-              <a:rPr lang="en-US" sz="2850" dirty="0" spc="11" kern="0">
+              <a:t> chưa</a:t>
+            </a:r>
+            <a:r>
+              <a:rPr lang="en-US" sz="2850" dirty="0" spc="3" kern="0">
                 <a:solidFill>
                   <a:srgbClr val="14161C"/>
                 </a:solidFill>
@@ -10011,10 +10011,10 @@
                 <a:ea typeface="Be Vietnam Pro SemiBold" pitchFamily="34" charset="-122"/>
                 <a:cs typeface="Be Vietnam Pro SemiBold" pitchFamily="34" charset="-120"/>
               </a:rPr>
-              <a:t> chưa</a:t>
-            </a:r>
-            <a:r>
-              <a:rPr lang="en-US" sz="2850" dirty="0" spc="3" kern="0">
+              <a:t> chắc</a:t>
+            </a:r>
+            <a:r>
+              <a:rPr lang="en-US" sz="2850" dirty="0" spc="1" kern="0">
                 <a:solidFill>
                   <a:srgbClr val="14161C"/>
                 </a:solidFill>
@@ -10022,10 +10022,10 @@
                 <a:ea typeface="Be Vietnam Pro SemiBold" pitchFamily="34" charset="-122"/>
                 <a:cs typeface="Be Vietnam Pro SemiBold" pitchFamily="34" charset="-120"/>
               </a:rPr>
-              <a:t> chắc</a:t>
-            </a:r>
-            <a:r>
-              <a:rPr lang="en-US" sz="2850" dirty="0" spc="0" kern="0">
+              <a:t> cần</a:t>
+            </a:r>
+            <a:r>
+              <a:rPr lang="en-US" sz="2850" dirty="0" spc="-6" kern="0">
                 <a:solidFill>
                   <a:srgbClr val="14161C"/>
                 </a:solidFill>
@@ -10033,10 +10033,10 @@
                 <a:ea typeface="Be Vietnam Pro SemiBold" pitchFamily="34" charset="-122"/>
                 <a:cs typeface="Be Vietnam Pro SemiBold" pitchFamily="34" charset="-120"/>
               </a:rPr>
-              <a:t> cần</a:t>
-            </a:r>
-            <a:r>
-              <a:rPr lang="en-US" sz="2850" dirty="0" spc="-6" kern="0">
+              <a:t> nhóm</a:t>
+            </a:r>
+            <a:r>
+              <a:rPr lang="en-US" sz="2850" dirty="0" spc="3" kern="0">
                 <a:solidFill>
                   <a:srgbClr val="14161C"/>
                 </a:solidFill>
@@ -10044,10 +10044,10 @@
                 <a:ea typeface="Be Vietnam Pro SemiBold" pitchFamily="34" charset="-122"/>
                 <a:cs typeface="Be Vietnam Pro SemiBold" pitchFamily="34" charset="-120"/>
               </a:rPr>
-              <a:t> nhóm nền</a:t>
-            </a:r>
-            <a:r>
-              <a:rPr lang="en-US" sz="2850" dirty="0" spc="-7" kern="0">
+              <a:t> riêng,</a:t>
+            </a:r>
+            <a:r>
+              <a:rPr lang="en-US" sz="2850" dirty="0" spc="-39" kern="0">
                 <a:solidFill>
                   <a:srgbClr val="14161C"/>
                 </a:solidFill>
@@ -10055,10 +10055,10 @@
                 <a:ea typeface="Be Vietnam Pro SemiBold" pitchFamily="34" charset="-122"/>
                 <a:cs typeface="Be Vietnam Pro SemiBold" pitchFamily="34" charset="-120"/>
               </a:rPr>
-              <a:t> tảng</a:t>
-            </a:r>
-            <a:r>
-              <a:rPr lang="en-US" sz="2850" dirty="0" spc="-12" kern="0">
+              <a:t> SLO</a:t>
+            </a:r>
+            <a:r>
+              <a:rPr lang="en-US" sz="2850" dirty="0" spc="0" kern="0">
                 <a:solidFill>
                   <a:srgbClr val="14161C"/>
                 </a:solidFill>
@@ -10066,10 +10066,10 @@
                 <a:ea typeface="Be Vietnam Pro SemiBold" pitchFamily="34" charset="-122"/>
                 <a:cs typeface="Be Vietnam Pro SemiBold" pitchFamily="34" charset="-120"/>
               </a:rPr>
-              <a:t> hay</a:t>
-            </a:r>
-            <a:r>
-              <a:rPr lang="en-US" sz="2850" dirty="0" spc="-32" kern="0">
+              <a:t> chính</a:t>
+            </a:r>
+            <a:r>
+              <a:rPr lang="en-US" sz="2850" dirty="0" spc="10" kern="0">
                 <a:solidFill>
                   <a:srgbClr val="14161C"/>
                 </a:solidFill>
@@ -10077,7 +10077,7 @@
                 <a:ea typeface="Be Vietnam Pro SemiBold" pitchFamily="34" charset="-122"/>
                 <a:cs typeface="Be Vietnam Pro SemiBold" pitchFamily="34" charset="-120"/>
               </a:rPr>
-              <a:t> SLO.</a:t>
+              <a:t> thức.</a:t>
             </a:r>
             <a:endParaRPr lang="en-US" sz="2850" dirty="0"/>
           </a:p>
@@ -10301,7 +10301,7 @@
               <a:t> cụ</a:t>
             </a:r>
             <a:r>
-              <a:rPr lang="en-US" sz="2850" dirty="0" spc="-1" kern="0">
+              <a:rPr lang="en-US" sz="2850" dirty="0" spc="-2" kern="0">
                 <a:solidFill>
                   <a:srgbClr val="14161C"/>
                 </a:solidFill>
@@ -10309,10 +10309,10 @@
                 <a:ea typeface="Be Vietnam Pro SemiBold" pitchFamily="34" charset="-122"/>
                 <a:cs typeface="Be Vietnam Pro SemiBold" pitchFamily="34" charset="-120"/>
               </a:rPr>
-              <a:t> thể</a:t>
-            </a:r>
-            <a:r>
-              <a:rPr lang="en-US" sz="2850" dirty="0" spc="-10" kern="0">
+              <a:t> thể,</a:t>
+            </a:r>
+            <a:r>
+              <a:rPr lang="en-US" sz="2850" dirty="0" spc="27" kern="0">
                 <a:solidFill>
                   <a:srgbClr val="14161C"/>
                 </a:solidFill>
@@ -10320,10 +10320,10 @@
                 <a:ea typeface="Be Vietnam Pro SemiBold" pitchFamily="34" charset="-122"/>
                 <a:cs typeface="Be Vietnam Pro SemiBold" pitchFamily="34" charset="-120"/>
               </a:rPr>
-              <a:t> thay</a:t>
-            </a:r>
-            <a:r>
-              <a:rPr lang="en-US" sz="2850" dirty="0" spc="2" kern="0">
+              <a:t> đừng</a:t>
+            </a:r>
+            <a:r>
+              <a:rPr lang="en-US" sz="2850" dirty="0" spc="15" kern="0">
                 <a:solidFill>
                   <a:srgbClr val="14161C"/>
                 </a:solidFill>
@@ -10331,10 +10331,10 @@
                 <a:ea typeface="Be Vietnam Pro SemiBold" pitchFamily="34" charset="-122"/>
                 <a:cs typeface="Be Vietnam Pro SemiBold" pitchFamily="34" charset="-120"/>
               </a:rPr>
-              <a:t> vì</a:t>
-            </a:r>
-            <a:r>
-              <a:rPr lang="en-US" sz="2850" dirty="0" spc="14" kern="0">
+              <a:t> dựa</a:t>
+            </a:r>
+            <a:r>
+              <a:rPr lang="en-US" sz="2850" dirty="0" spc="-12" kern="0">
                 <a:solidFill>
                   <a:srgbClr val="14161C"/>
                 </a:solidFill>
@@ -10342,21 +10342,10 @@
                 <a:ea typeface="Be Vietnam Pro SemiBold" pitchFamily="34" charset="-122"/>
                 <a:cs typeface="Be Vietnam Pro SemiBold" pitchFamily="34" charset="-120"/>
               </a:rPr>
-              <a:t> dựa</a:t>
-            </a:r>
-            <a:r>
-              <a:rPr lang="en-US" sz="2850" dirty="0" spc="-12" kern="0">
-                <a:solidFill>
-                  <a:srgbClr val="14161C"/>
-                </a:solidFill>
-                <a:latin typeface="Be Vietnam Pro SemiBold" pitchFamily="34" charset="0"/>
-                <a:ea typeface="Be Vietnam Pro SemiBold" pitchFamily="34" charset="-122"/>
-                <a:cs typeface="Be Vietnam Pro SemiBold" pitchFamily="34" charset="-120"/>
-              </a:rPr>
               <a:t> vào</a:t>
             </a:r>
             <a:r>
-              <a:rPr lang="en-US" sz="2850" dirty="0" spc="-9" kern="0">
+              <a:rPr lang="en-US" sz="2850" dirty="0" spc="-10" kern="0">
                 <a:solidFill>
                   <a:srgbClr val="14161C"/>
                 </a:solidFill>

</xml_diff>

<commit_message>
Slides: keep 'thường' on the slide 2 title (sd-13-019)
Co-Authored-By: Claude Sonnet 5.5 <noreply@anthropic.com>
Claude-Session: https://claude.ai/code/session_01EhxTYrCJpuk4mcqCLwPdds
</commit_message>
<xml_diff>
--- a/system-design-101/vi/lessons/sd-13-019/slides/sd-13-019.pptx
+++ b/system-design-101/vi/lessons/sd-13-019/slides/sd-13-019.pptx
@@ -4254,7 +4254,7 @@
               <a:t> gian</a:t>
             </a:r>
             <a:r>
-              <a:rPr lang="en-US" sz="6900" dirty="0" spc="-1" kern="0">
+              <a:rPr lang="en-US" sz="6900" dirty="0" spc="-61" kern="0">
                 <a:solidFill>
                   <a:srgbClr val="14161C"/>
                 </a:solidFill>
@@ -4262,10 +4262,10 @@
                 <a:ea typeface="Bricolage Grotesque ExtraBold" pitchFamily="34" charset="-122"/>
                 <a:cs typeface="Bricolage Grotesque ExtraBold" pitchFamily="34" charset="-120"/>
               </a:rPr>
-              <a:t> mất</a:t>
-            </a:r>
-            <a:r>
-              <a:rPr lang="en-US" sz="6900" dirty="0" spc="1" kern="0">
+              <a:t> thường</a:t>
+            </a:r>
+            <a:r>
+              <a:rPr lang="en-US" sz="6900" dirty="0" spc="-2" kern="0">
                 <a:solidFill>
                   <a:srgbClr val="14161C"/>
                 </a:solidFill>
@@ -4273,10 +4273,10 @@
                 <a:ea typeface="Bricolage Grotesque ExtraBold" pitchFamily="34" charset="-122"/>
                 <a:cs typeface="Bricolage Grotesque ExtraBold" pitchFamily="34" charset="-120"/>
               </a:rPr>
-              <a:t> ở</a:t>
-            </a:r>
-            <a:r>
-              <a:rPr lang="en-US" sz="6900" dirty="0" spc="-1" kern="0">
+              <a:t> mất</a:t>
+            </a:r>
+            <a:r>
+              <a:rPr lang="en-US" sz="6900" dirty="0" spc="0" kern="0">
                 <a:solidFill>
                   <a:srgbClr val="14161C"/>
                 </a:solidFill>
@@ -4284,7 +4284,7 @@
                 <a:ea typeface="Bricolage Grotesque ExtraBold" pitchFamily="34" charset="-122"/>
                 <a:cs typeface="Bricolage Grotesque ExtraBold" pitchFamily="34" charset="-120"/>
               </a:rPr>
-              <a:t> chỗ</a:t>
+              <a:t> ở</a:t>
             </a:r>
             <a:r>
               <a:rPr lang="en-US" sz="6900" dirty="0" spc="3" kern="0">

</xml_diff>